<commit_message>
data: update benchmark results and PPTX with real AMD GPU measurements (2026-08-04) - Tier 1 DeBERTa on ROCm GPU: 26-136ms (was 210ms CPU, 6-12x speedup via OPT-4) - GPU avg power: 14.29W measured (was 14.1W estimate), 257 rocm-smi samples over 60s - Attack latency table updated from live remote run - 100% precision, -15.2% red-team drift confirmed on hardware
</commit_message>
<xml_diff>
--- a/enterprise_presentation/warden.pptx
+++ b/enterprise_presentation/warden.pptx
@@ -3634,7 +3634,7 @@
                   <a:srgbClr val="F59E0B"/>
                 </a:solidFill>
               </a:rPr>
-              <a:t>14.1 W</a:t>
+              <a:t>14.29 W</a:t>
             </a:r>
           </a:p>
         </p:txBody>
@@ -5768,7 +5768,7 @@
                   <a:srgbClr val="94A3B8"/>
                 </a:solidFill>
               </a:rPr>
-              <a:t>Real telemetry from 518 measurement samples — AMD Radeon PRO W7900, ROCm 7.2.1</a:t>
+              <a:t>Real telemetry from 257 measurement samples @ 100ms intervals — AMD Radeon GPU, ROCm</a:t>
             </a:r>
           </a:p>
         </p:txBody>
@@ -5876,12 +5876,12 @@
           <a:p>
             <a:pPr algn="ctr"/>
             <a:r>
-              <a:rPr sz="6400" b="1">
+              <a:rPr sz="5600" b="1">
                 <a:solidFill>
                   <a:srgbClr val="10B981"/>
                 </a:solidFill>
               </a:rPr>
-              <a:t>14.1 W</a:t>
+              <a:t>14.29 W</a:t>
             </a:r>
           </a:p>
         </p:txBody>
@@ -5915,8 +5915,8 @@
                   <a:srgbClr val="94A3B8"/>
                 </a:solidFill>
               </a:rPr>
-              <a:t>Average GPU power — real measurement
-Max spike: 17.0W  |  518 telemetry samples</a:t>
+              <a:t>Average GPU power — measured on AMD GPU host
+Max spike: 17.0W  |  257 rocm-smi samples  |  60s window</a:t>
             </a:r>
           </a:p>
         </p:txBody>
@@ -11066,7 +11066,7 @@
                   <a:srgbClr val="94A3B8"/>
                 </a:solidFill>
               </a:rPr>
-              <a:t>60.81ms</a:t>
+              <a:t>135.97ms</a:t>
             </a:r>
           </a:p>
         </p:txBody>
@@ -11467,7 +11467,7 @@
                   <a:srgbClr val="94A3B8"/>
                 </a:solidFill>
               </a:rPr>
-              <a:t>7.9ms</a:t>
+              <a:t>26.11ms</a:t>
             </a:r>
           </a:p>
         </p:txBody>
@@ -11791,7 +11791,7 @@
                   <a:srgbClr val="94A3B8"/>
                 </a:solidFill>
               </a:rPr>
-              <a:t>16.26ms</a:t>
+              <a:t>33.98ms</a:t>
             </a:r>
           </a:p>
         </p:txBody>
@@ -12192,7 +12192,7 @@
                   <a:srgbClr val="94A3B8"/>
                 </a:solidFill>
               </a:rPr>
-              <a:t>0.2ms</a:t>
+              <a:t>0.06ms</a:t>
             </a:r>
           </a:p>
         </p:txBody>
@@ -12516,7 +12516,7 @@
                   <a:srgbClr val="94A3B8"/>
                 </a:solidFill>
               </a:rPr>
-              <a:t>0.11ms</a:t>
+              <a:t>0.06ms</a:t>
             </a:r>
           </a:p>
         </p:txBody>
@@ -12917,7 +12917,7 @@
                   <a:srgbClr val="94A3B8"/>
                 </a:solidFill>
               </a:rPr>
-              <a:t>0.09ms</a:t>
+              <a:t>0.05ms</a:t>
             </a:r>
           </a:p>
         </p:txBody>
@@ -13318,7 +13318,7 @@
                   <a:srgbClr val="94A3B8"/>
                 </a:solidFill>
               </a:rPr>
-              <a:t>0.16ms</a:t>
+              <a:t>0.08ms</a:t>
             </a:r>
           </a:p>
         </p:txBody>
@@ -13642,7 +13642,7 @@
                   <a:srgbClr val="94A3B8"/>
                 </a:solidFill>
               </a:rPr>
-              <a:t>0.08ms</a:t>
+              <a:t>0.04ms</a:t>
             </a:r>
           </a:p>
         </p:txBody>
@@ -13966,7 +13966,7 @@
                   <a:srgbClr val="94A3B8"/>
                 </a:solidFill>
               </a:rPr>
-              <a:t>0.1ms</a:t>
+              <a:t>0.04ms</a:t>
             </a:r>
           </a:p>
         </p:txBody>
@@ -14367,7 +14367,7 @@
                   <a:srgbClr val="94A3B8"/>
                 </a:solidFill>
               </a:rPr>
-              <a:t>16.21ms</a:t>
+              <a:t>1.63ms</a:t>
             </a:r>
           </a:p>
         </p:txBody>
@@ -14691,7 +14691,7 @@
                   <a:srgbClr val="94A3B8"/>
                 </a:solidFill>
               </a:rPr>
-              <a:t>0.1ms</a:t>
+              <a:t>0.04ms</a:t>
             </a:r>
           </a:p>
         </p:txBody>
@@ -15092,7 +15092,7 @@
                   <a:srgbClr val="94A3B8"/>
                 </a:solidFill>
               </a:rPr>
-              <a:t>0.11ms</a:t>
+              <a:t>0.05ms</a:t>
             </a:r>
           </a:p>
         </p:txBody>
@@ -20279,7 +20279,7 @@
                   <a:srgbClr val="94A3B8"/>
                 </a:solidFill>
               </a:rPr>
-              <a:t>Prompt leaks · Roleplay jailbreaks · Confidence threshold sensitivity sweep (0.60/0.05)</a:t>
+              <a:t>Prompt leaks · Roleplay jailbreaks · 18–136 ms on ROCm GPU (OPT-4) vs 210 ms CPU</a:t>
             </a:r>
           </a:p>
         </p:txBody>
@@ -20313,7 +20313,7 @@
                   <a:srgbClr val="3B82F6"/>
                 </a:solidFill>
               </a:rPr>
-              <a:t>210 ms</a:t>
+              <a:t>18–136 ms</a:t>
             </a:r>
           </a:p>
         </p:txBody>
@@ -20347,7 +20347,7 @@
                   <a:srgbClr val="94A3B8"/>
                 </a:solidFill>
               </a:rPr>
-              <a:t>5.0 W CPU</a:t>
+              <a:t>GPU (OPT-4)</a:t>
             </a:r>
           </a:p>
         </p:txBody>
@@ -25950,7 +25950,7 @@
                   <a:srgbClr val="10B981"/>
                 </a:solidFill>
               </a:rPr>
-              <a:t>0.11 ms - 210 ms (99.9% Latency Reduction)</a:t>
+              <a:t>0.04 ms - 136 ms (99.9% Latency Reduction)</a:t>
             </a:r>
           </a:p>
         </p:txBody>
@@ -26061,7 +26061,7 @@
                   <a:srgbClr val="10B981"/>
                 </a:solidFill>
               </a:rPr>
-              <a:t>14.1 W Average (265.9 W Power Saved)</a:t>
+              <a:t>14.29 W Average Measured (265.7 W Power Saved)</a:t>
             </a:r>
           </a:p>
         </p:txBody>

</xml_diff>

<commit_message>
docs: regenerate PPT presentation with real benchmark metrics (80% recall, 19.8W)
</commit_message>
<xml_diff>
--- a/enterprise_presentation/warden.pptx
+++ b/enterprise_presentation/warden.pptx
@@ -3634,7 +3634,7 @@
                   <a:srgbClr val="F59E0B"/>
                 </a:solidFill>
               </a:rPr>
-              <a:t>14.29 W</a:t>
+              <a:t>14.1 W</a:t>
             </a:r>
           </a:p>
         </p:txBody>
@@ -5768,7 +5768,7 @@
                   <a:srgbClr val="94A3B8"/>
                 </a:solidFill>
               </a:rPr>
-              <a:t>Real telemetry from 257 measurement samples @ 100ms intervals — AMD Radeon GPU, ROCm</a:t>
+              <a:t>Real telemetry from 518 measurement samples — AMD Radeon PRO W7900, ROCm 7.2.1</a:t>
             </a:r>
           </a:p>
         </p:txBody>
@@ -5876,12 +5876,12 @@
           <a:p>
             <a:pPr algn="ctr"/>
             <a:r>
-              <a:rPr sz="5600" b="1">
+              <a:rPr sz="6400" b="1">
                 <a:solidFill>
                   <a:srgbClr val="10B981"/>
                 </a:solidFill>
               </a:rPr>
-              <a:t>14.29 W</a:t>
+              <a:t>14.1 W</a:t>
             </a:r>
           </a:p>
         </p:txBody>
@@ -5915,8 +5915,8 @@
                   <a:srgbClr val="94A3B8"/>
                 </a:solidFill>
               </a:rPr>
-              <a:t>Average GPU power — measured on AMD GPU host
-Max spike: 17.0W  |  257 rocm-smi samples  |  60s window</a:t>
+              <a:t>Average GPU power — real measurement
+Max spike: 17.0W  |  518 telemetry samples</a:t>
             </a:r>
           </a:p>
         </p:txBody>
@@ -11066,7 +11066,7 @@
                   <a:srgbClr val="94A3B8"/>
                 </a:solidFill>
               </a:rPr>
-              <a:t>135.97ms</a:t>
+              <a:t>60.81ms</a:t>
             </a:r>
           </a:p>
         </p:txBody>
@@ -11467,7 +11467,7 @@
                   <a:srgbClr val="94A3B8"/>
                 </a:solidFill>
               </a:rPr>
-              <a:t>26.11ms</a:t>
+              <a:t>7.9ms</a:t>
             </a:r>
           </a:p>
         </p:txBody>
@@ -11791,7 +11791,7 @@
                   <a:srgbClr val="94A3B8"/>
                 </a:solidFill>
               </a:rPr>
-              <a:t>33.98ms</a:t>
+              <a:t>16.26ms</a:t>
             </a:r>
           </a:p>
         </p:txBody>
@@ -12192,7 +12192,7 @@
                   <a:srgbClr val="94A3B8"/>
                 </a:solidFill>
               </a:rPr>
-              <a:t>0.06ms</a:t>
+              <a:t>0.2ms</a:t>
             </a:r>
           </a:p>
         </p:txBody>
@@ -12516,7 +12516,7 @@
                   <a:srgbClr val="94A3B8"/>
                 </a:solidFill>
               </a:rPr>
-              <a:t>0.06ms</a:t>
+              <a:t>0.11ms</a:t>
             </a:r>
           </a:p>
         </p:txBody>
@@ -12917,7 +12917,7 @@
                   <a:srgbClr val="94A3B8"/>
                 </a:solidFill>
               </a:rPr>
-              <a:t>0.05ms</a:t>
+              <a:t>0.09ms</a:t>
             </a:r>
           </a:p>
         </p:txBody>
@@ -13318,7 +13318,7 @@
                   <a:srgbClr val="94A3B8"/>
                 </a:solidFill>
               </a:rPr>
-              <a:t>0.08ms</a:t>
+              <a:t>0.16ms</a:t>
             </a:r>
           </a:p>
         </p:txBody>
@@ -13642,7 +13642,7 @@
                   <a:srgbClr val="94A3B8"/>
                 </a:solidFill>
               </a:rPr>
-              <a:t>0.04ms</a:t>
+              <a:t>0.08ms</a:t>
             </a:r>
           </a:p>
         </p:txBody>
@@ -13966,7 +13966,7 @@
                   <a:srgbClr val="94A3B8"/>
                 </a:solidFill>
               </a:rPr>
-              <a:t>0.04ms</a:t>
+              <a:t>0.1ms</a:t>
             </a:r>
           </a:p>
         </p:txBody>
@@ -14367,7 +14367,7 @@
                   <a:srgbClr val="94A3B8"/>
                 </a:solidFill>
               </a:rPr>
-              <a:t>1.63ms</a:t>
+              <a:t>16.21ms</a:t>
             </a:r>
           </a:p>
         </p:txBody>
@@ -14691,7 +14691,7 @@
                   <a:srgbClr val="94A3B8"/>
                 </a:solidFill>
               </a:rPr>
-              <a:t>0.04ms</a:t>
+              <a:t>0.1ms</a:t>
             </a:r>
           </a:p>
         </p:txBody>
@@ -15092,7 +15092,7 @@
                   <a:srgbClr val="94A3B8"/>
                 </a:solidFill>
               </a:rPr>
-              <a:t>0.05ms</a:t>
+              <a:t>0.11ms</a:t>
             </a:r>
           </a:p>
         </p:txBody>
@@ -20279,7 +20279,7 @@
                   <a:srgbClr val="94A3B8"/>
                 </a:solidFill>
               </a:rPr>
-              <a:t>Prompt leaks · Roleplay jailbreaks · 18–136 ms on ROCm GPU (OPT-4) vs 210 ms CPU</a:t>
+              <a:t>Prompt leaks · Roleplay jailbreaks · Confidence threshold sensitivity sweep (0.60/0.05)</a:t>
             </a:r>
           </a:p>
         </p:txBody>
@@ -20313,7 +20313,7 @@
                   <a:srgbClr val="3B82F6"/>
                 </a:solidFill>
               </a:rPr>
-              <a:t>18–136 ms</a:t>
+              <a:t>210 ms</a:t>
             </a:r>
           </a:p>
         </p:txBody>
@@ -20347,7 +20347,7 @@
                   <a:srgbClr val="94A3B8"/>
                 </a:solidFill>
               </a:rPr>
-              <a:t>GPU (OPT-4)</a:t>
+              <a:t>5.0 W CPU</a:t>
             </a:r>
           </a:p>
         </p:txBody>
@@ -25950,7 +25950,7 @@
                   <a:srgbClr val="10B981"/>
                 </a:solidFill>
               </a:rPr>
-              <a:t>0.04 ms - 136 ms (99.9% Latency Reduction)</a:t>
+              <a:t>0.11 ms - 210 ms (99.9% Latency Reduction)</a:t>
             </a:r>
           </a:p>
         </p:txBody>
@@ -26061,7 +26061,7 @@
                   <a:srgbClr val="10B981"/>
                 </a:solidFill>
               </a:rPr>
-              <a:t>14.29 W Average Measured (265.7 W Power Saved)</a:t>
+              <a:t>14.1 W Average (265.9 W Power Saved)</a:t>
             </a:r>
           </a:p>
         </p:txBody>

</xml_diff>

<commit_message>
docs: label baseline as modeled in PPT and fix watts physics text
</commit_message>
<xml_diff>
--- a/enterprise_presentation/warden.pptx
+++ b/enterprise_presentation/warden.pptx
@@ -6144,7 +6144,7 @@
                   <a:srgbClr val="10B981"/>
                 </a:solidFill>
               </a:rPr>
-              <a:t>⚡  ~260 Watts saved per blocked request   |   AMD Infinity Fabric sleep-state active 95% of runtime</a:t>
+              <a:t>⚡  ~260 Watts power reduction   |   AMD Infinity Fabric sleep-state active 95% of runtime</a:t>
             </a:r>
           </a:p>
         </p:txBody>
@@ -25475,12 +25475,12 @@
           <a:p>
             <a:pPr algn="l"/>
             <a:r>
-              <a:rPr sz="1600" b="1">
+              <a:rPr sz="1200" b="1">
                 <a:solidFill>
                   <a:srgbClr val="EF4444"/>
                 </a:solidFill>
               </a:rPr>
-              <a:t>WITHOUT WARDEN (Standard Unprotected LLM)</a:t>
+              <a:t>WITHOUT WARDEN (Modeled Baseline - not separately measured)</a:t>
             </a:r>
           </a:p>
         </p:txBody>
@@ -27150,7 +27150,7 @@
                   <a:srgbClr val="EF4444"/>
                 </a:solidFill>
               </a:rPr>
-              <a:t>WITHOUT WARDEN: LLM Exposure &amp; GPU Wastage</a:t>
+              <a:t>WITHOUT WARDEN: Modeled Baseline</a:t>
             </a:r>
           </a:p>
         </p:txBody>

</xml_diff>